<commit_message>
Updated lecture for 2026
</commit_message>
<xml_diff>
--- a/powerpoints/Introduction.pptx
+++ b/powerpoints/Introduction.pptx
@@ -5,7 +5,7 @@
     <p:sldMasterId id="2147483648" r:id="rId1"/>
   </p:sldMasterIdLst>
   <p:notesMasterIdLst>
-    <p:notesMasterId r:id="rId15"/>
+    <p:notesMasterId r:id="rId16"/>
   </p:notesMasterIdLst>
   <p:sldIdLst>
     <p:sldId id="256" r:id="rId2"/>
@@ -21,6 +21,7 @@
     <p:sldId id="354" r:id="rId12"/>
     <p:sldId id="355" r:id="rId13"/>
     <p:sldId id="352" r:id="rId14"/>
+    <p:sldId id="356" r:id="rId15"/>
   </p:sldIdLst>
   <p:sldSz cx="12192000" cy="6858000"/>
   <p:notesSz cx="6858000" cy="9144000"/>
@@ -209,7 +210,7 @@
           <a:p>
             <a:fld id="{BF3E0636-8A2E-4043-881A-1014A5CF3828}" type="datetimeFigureOut">
               <a:rPr lang="en-US" smtClean="0"/>
-              <a:t>10/27/25</a:t>
+              <a:t>4/27/26</a:t>
             </a:fld>
             <a:endParaRPr lang="en-US"/>
           </a:p>
@@ -971,6 +972,114 @@
 </p:notes>
 </file>
 
+<file path=ppt/notesSlides/notesSlide14.xml><?xml version="1.0" encoding="utf-8"?>
+<p:notes xmlns:a="http://schemas.openxmlformats.org/drawingml/2006/main" xmlns:r="http://schemas.openxmlformats.org/officeDocument/2006/relationships" xmlns:p="http://schemas.openxmlformats.org/presentationml/2006/main">
+  <p:cSld>
+    <p:spTree>
+      <p:nvGrpSpPr>
+        <p:cNvPr id="1" name="">
+          <a:extLst>
+            <a:ext uri="{FF2B5EF4-FFF2-40B4-BE49-F238E27FC236}">
+              <a16:creationId xmlns:a16="http://schemas.microsoft.com/office/drawing/2014/main" id="{28DCCC7F-0541-228A-E94E-4A5E3B8990C8}"/>
+            </a:ext>
+          </a:extLst>
+        </p:cNvPr>
+        <p:cNvGrpSpPr/>
+        <p:nvPr/>
+      </p:nvGrpSpPr>
+      <p:grpSpPr>
+        <a:xfrm>
+          <a:off x="0" y="0"/>
+          <a:ext cx="0" cy="0"/>
+          <a:chOff x="0" y="0"/>
+          <a:chExt cx="0" cy="0"/>
+        </a:xfrm>
+      </p:grpSpPr>
+      <p:sp>
+        <p:nvSpPr>
+          <p:cNvPr id="2" name="Slide Image Placeholder 1">
+            <a:extLst>
+              <a:ext uri="{FF2B5EF4-FFF2-40B4-BE49-F238E27FC236}">
+                <a16:creationId xmlns:a16="http://schemas.microsoft.com/office/drawing/2014/main" id="{8EF12595-145A-D782-1A4F-76176C9F5568}"/>
+              </a:ext>
+            </a:extLst>
+          </p:cNvPr>
+          <p:cNvSpPr>
+            <a:spLocks noGrp="1" noRot="1" noChangeAspect="1"/>
+          </p:cNvSpPr>
+          <p:nvPr>
+            <p:ph type="sldImg"/>
+          </p:nvPr>
+        </p:nvSpPr>
+        <p:spPr/>
+      </p:sp>
+      <p:sp>
+        <p:nvSpPr>
+          <p:cNvPr id="3" name="Notes Placeholder 2">
+            <a:extLst>
+              <a:ext uri="{FF2B5EF4-FFF2-40B4-BE49-F238E27FC236}">
+                <a16:creationId xmlns:a16="http://schemas.microsoft.com/office/drawing/2014/main" id="{E1CE6E01-6D0A-0548-752C-DA7A29DD11F9}"/>
+              </a:ext>
+            </a:extLst>
+          </p:cNvPr>
+          <p:cNvSpPr>
+            <a:spLocks noGrp="1"/>
+          </p:cNvSpPr>
+          <p:nvPr>
+            <p:ph type="body" idx="1"/>
+          </p:nvPr>
+        </p:nvSpPr>
+        <p:spPr/>
+        <p:txBody>
+          <a:bodyPr/>
+          <a:lstStyle/>
+          <a:p>
+            <a:endParaRPr lang="en-US" dirty="0"/>
+          </a:p>
+        </p:txBody>
+      </p:sp>
+      <p:sp>
+        <p:nvSpPr>
+          <p:cNvPr id="4" name="Slide Number Placeholder 3">
+            <a:extLst>
+              <a:ext uri="{FF2B5EF4-FFF2-40B4-BE49-F238E27FC236}">
+                <a16:creationId xmlns:a16="http://schemas.microsoft.com/office/drawing/2014/main" id="{30D037B3-0C48-A38C-D6EC-BDCBE9CA61AA}"/>
+              </a:ext>
+            </a:extLst>
+          </p:cNvPr>
+          <p:cNvSpPr>
+            <a:spLocks noGrp="1"/>
+          </p:cNvSpPr>
+          <p:nvPr>
+            <p:ph type="sldNum" sz="quarter" idx="10"/>
+          </p:nvPr>
+        </p:nvSpPr>
+        <p:spPr/>
+        <p:txBody>
+          <a:bodyPr/>
+          <a:lstStyle/>
+          <a:p>
+            <a:fld id="{6B573416-B7DF-8D4F-92B3-793638796327}" type="slidenum">
+              <a:rPr lang="en-US" smtClean="0"/>
+              <a:t>14</a:t>
+            </a:fld>
+            <a:endParaRPr lang="en-US"/>
+          </a:p>
+        </p:txBody>
+      </p:sp>
+    </p:spTree>
+    <p:extLst>
+      <p:ext uri="{BB962C8B-B14F-4D97-AF65-F5344CB8AC3E}">
+        <p14:creationId xmlns:p14="http://schemas.microsoft.com/office/powerpoint/2010/main" val="428152235"/>
+      </p:ext>
+    </p:extLst>
+  </p:cSld>
+  <p:clrMapOvr>
+    <a:masterClrMapping/>
+  </p:clrMapOvr>
+</p:notes>
+</file>
+
 <file path=ppt/notesSlides/notesSlide2.xml><?xml version="1.0" encoding="utf-8"?>
 <p:notes xmlns:a="http://schemas.openxmlformats.org/drawingml/2006/main" xmlns:r="http://schemas.openxmlformats.org/officeDocument/2006/relationships" xmlns:p="http://schemas.openxmlformats.org/presentationml/2006/main" showMasterSp="0" showMasterPhAnim="0">
   <p:cSld>
@@ -1797,7 +1906,7 @@
           <a:p>
             <a:fld id="{F863BEF8-C8D8-2848-8261-78C146860174}" type="datetimeFigureOut">
               <a:rPr lang="en-US" smtClean="0"/>
-              <a:t>10/27/25</a:t>
+              <a:t>4/27/26</a:t>
             </a:fld>
             <a:endParaRPr lang="en-US"/>
           </a:p>
@@ -1965,7 +2074,7 @@
           <a:p>
             <a:fld id="{F863BEF8-C8D8-2848-8261-78C146860174}" type="datetimeFigureOut">
               <a:rPr lang="en-US" smtClean="0"/>
-              <a:t>10/27/25</a:t>
+              <a:t>4/27/26</a:t>
             </a:fld>
             <a:endParaRPr lang="en-US"/>
           </a:p>
@@ -2143,7 +2252,7 @@
           <a:p>
             <a:fld id="{F863BEF8-C8D8-2848-8261-78C146860174}" type="datetimeFigureOut">
               <a:rPr lang="en-US" smtClean="0"/>
-              <a:t>10/27/25</a:t>
+              <a:t>4/27/26</a:t>
             </a:fld>
             <a:endParaRPr lang="en-US"/>
           </a:p>
@@ -2666,7 +2775,7 @@
           <a:p>
             <a:fld id="{F863BEF8-C8D8-2848-8261-78C146860174}" type="datetimeFigureOut">
               <a:rPr lang="en-US" smtClean="0"/>
-              <a:t>10/27/25</a:t>
+              <a:t>4/27/26</a:t>
             </a:fld>
             <a:endParaRPr lang="en-US"/>
           </a:p>
@@ -2911,7 +3020,7 @@
           <a:p>
             <a:fld id="{F863BEF8-C8D8-2848-8261-78C146860174}" type="datetimeFigureOut">
               <a:rPr lang="en-US" smtClean="0"/>
-              <a:t>10/27/25</a:t>
+              <a:t>4/27/26</a:t>
             </a:fld>
             <a:endParaRPr lang="en-US"/>
           </a:p>
@@ -3140,7 +3249,7 @@
           <a:p>
             <a:fld id="{F863BEF8-C8D8-2848-8261-78C146860174}" type="datetimeFigureOut">
               <a:rPr lang="en-US" smtClean="0"/>
-              <a:t>10/27/25</a:t>
+              <a:t>4/27/26</a:t>
             </a:fld>
             <a:endParaRPr lang="en-US"/>
           </a:p>
@@ -3504,7 +3613,7 @@
           <a:p>
             <a:fld id="{F863BEF8-C8D8-2848-8261-78C146860174}" type="datetimeFigureOut">
               <a:rPr lang="en-US" smtClean="0"/>
-              <a:t>10/27/25</a:t>
+              <a:t>4/27/26</a:t>
             </a:fld>
             <a:endParaRPr lang="en-US"/>
           </a:p>
@@ -3621,7 +3730,7 @@
           <a:p>
             <a:fld id="{F863BEF8-C8D8-2848-8261-78C146860174}" type="datetimeFigureOut">
               <a:rPr lang="en-US" smtClean="0"/>
-              <a:t>10/27/25</a:t>
+              <a:t>4/27/26</a:t>
             </a:fld>
             <a:endParaRPr lang="en-US"/>
           </a:p>
@@ -3716,7 +3825,7 @@
           <a:p>
             <a:fld id="{F863BEF8-C8D8-2848-8261-78C146860174}" type="datetimeFigureOut">
               <a:rPr lang="en-US" smtClean="0"/>
-              <a:t>10/27/25</a:t>
+              <a:t>4/27/26</a:t>
             </a:fld>
             <a:endParaRPr lang="en-US"/>
           </a:p>
@@ -3991,7 +4100,7 @@
           <a:p>
             <a:fld id="{F863BEF8-C8D8-2848-8261-78C146860174}" type="datetimeFigureOut">
               <a:rPr lang="en-US" smtClean="0"/>
-              <a:t>10/27/25</a:t>
+              <a:t>4/27/26</a:t>
             </a:fld>
             <a:endParaRPr lang="en-US"/>
           </a:p>
@@ -4243,7 +4352,7 @@
           <a:p>
             <a:fld id="{F863BEF8-C8D8-2848-8261-78C146860174}" type="datetimeFigureOut">
               <a:rPr lang="en-US" smtClean="0"/>
-              <a:t>10/27/25</a:t>
+              <a:t>4/27/26</a:t>
             </a:fld>
             <a:endParaRPr lang="en-US"/>
           </a:p>
@@ -4454,7 +4563,7 @@
           <a:p>
             <a:fld id="{F863BEF8-C8D8-2848-8261-78C146860174}" type="datetimeFigureOut">
               <a:rPr lang="en-US" smtClean="0"/>
-              <a:t>10/27/25</a:t>
+              <a:t>4/27/26</a:t>
             </a:fld>
             <a:endParaRPr lang="en-US"/>
           </a:p>
@@ -5446,6 +5555,126 @@
     <p:extLst>
       <p:ext uri="{BB962C8B-B14F-4D97-AF65-F5344CB8AC3E}">
         <p14:creationId xmlns:p14="http://schemas.microsoft.com/office/powerpoint/2010/main" val="4126168969"/>
+      </p:ext>
+    </p:extLst>
+  </p:cSld>
+  <p:clrMapOvr>
+    <a:masterClrMapping/>
+  </p:clrMapOvr>
+</p:sld>
+</file>
+
+<file path=ppt/slides/slide14.xml><?xml version="1.0" encoding="utf-8"?>
+<p:sld xmlns:a="http://schemas.openxmlformats.org/drawingml/2006/main" xmlns:r="http://schemas.openxmlformats.org/officeDocument/2006/relationships" xmlns:p="http://schemas.openxmlformats.org/presentationml/2006/main">
+  <p:cSld>
+    <p:spTree>
+      <p:nvGrpSpPr>
+        <p:cNvPr id="1" name="">
+          <a:extLst>
+            <a:ext uri="{FF2B5EF4-FFF2-40B4-BE49-F238E27FC236}">
+              <a16:creationId xmlns:a16="http://schemas.microsoft.com/office/drawing/2014/main" id="{7C27A494-0280-69B5-BA4C-59FF1A0CB631}"/>
+            </a:ext>
+          </a:extLst>
+        </p:cNvPr>
+        <p:cNvGrpSpPr/>
+        <p:nvPr/>
+      </p:nvGrpSpPr>
+      <p:grpSpPr>
+        <a:xfrm>
+          <a:off x="0" y="0"/>
+          <a:ext cx="0" cy="0"/>
+          <a:chOff x="0" y="0"/>
+          <a:chExt cx="0" cy="0"/>
+        </a:xfrm>
+      </p:grpSpPr>
+      <p:sp>
+        <p:nvSpPr>
+          <p:cNvPr id="2" name="Title 1">
+            <a:extLst>
+              <a:ext uri="{FF2B5EF4-FFF2-40B4-BE49-F238E27FC236}">
+                <a16:creationId xmlns:a16="http://schemas.microsoft.com/office/drawing/2014/main" id="{A14BDA30-1B26-EDC1-CEAF-20A78CB6BE81}"/>
+              </a:ext>
+            </a:extLst>
+          </p:cNvPr>
+          <p:cNvSpPr>
+            <a:spLocks noGrp="1"/>
+          </p:cNvSpPr>
+          <p:nvPr>
+            <p:ph type="title"/>
+          </p:nvPr>
+        </p:nvSpPr>
+        <p:spPr/>
+        <p:txBody>
+          <a:bodyPr>
+            <a:normAutofit/>
+          </a:bodyPr>
+          <a:lstStyle/>
+          <a:p>
+            <a:r>
+              <a:rPr lang="en-US" sz="4000" dirty="0"/>
+              <a:t>Why about using Cursor/Claude/</a:t>
+            </a:r>
+            <a:r>
+              <a:rPr lang="en-US" sz="4000" dirty="0" err="1"/>
+              <a:t>etc</a:t>
+            </a:r>
+            <a:r>
+              <a:rPr lang="en-US" sz="4000" dirty="0"/>
+              <a:t>?</a:t>
+            </a:r>
+          </a:p>
+        </p:txBody>
+      </p:sp>
+      <p:sp>
+        <p:nvSpPr>
+          <p:cNvPr id="4" name="Content Placeholder 2">
+            <a:extLst>
+              <a:ext uri="{FF2B5EF4-FFF2-40B4-BE49-F238E27FC236}">
+                <a16:creationId xmlns:a16="http://schemas.microsoft.com/office/drawing/2014/main" id="{4CA3008A-D342-CCF1-B790-588D01EC3B8C}"/>
+              </a:ext>
+            </a:extLst>
+          </p:cNvPr>
+          <p:cNvSpPr>
+            <a:spLocks noGrp="1"/>
+          </p:cNvSpPr>
+          <p:nvPr>
+            <p:ph idx="1"/>
+          </p:nvPr>
+        </p:nvSpPr>
+        <p:spPr>
+          <a:xfrm>
+            <a:off x="841248" y="1825625"/>
+            <a:ext cx="9507311" cy="4351338"/>
+          </a:xfrm>
+        </p:spPr>
+        <p:txBody>
+          <a:bodyPr>
+            <a:noAutofit/>
+          </a:bodyPr>
+          <a:lstStyle/>
+          <a:p>
+            <a:r>
+              <a:rPr lang="en-US" sz="2600" dirty="0"/>
+              <a:t>You can use it</a:t>
+            </a:r>
+          </a:p>
+          <a:p>
+            <a:r>
+              <a:rPr lang="en-US" sz="2600" dirty="0"/>
+              <a:t>Understanding how things work will enhance your ability to utilize </a:t>
+            </a:r>
+            <a:r>
+              <a:rPr lang="en-US" sz="2600"/>
+              <a:t>these tools</a:t>
+            </a:r>
+            <a:endParaRPr lang="en-US" sz="2600" dirty="0"/>
+          </a:p>
+        </p:txBody>
+      </p:sp>
+    </p:spTree>
+    <p:extLst>
+      <p:ext uri="{BB962C8B-B14F-4D97-AF65-F5344CB8AC3E}">
+        <p14:creationId xmlns:p14="http://schemas.microsoft.com/office/powerpoint/2010/main" val="3190058019"/>
       </p:ext>
     </p:extLst>
   </p:cSld>

</xml_diff>

<commit_message>
Added changes that happened during presentation
</commit_message>
<xml_diff>
--- a/powerpoints/Introduction.pptx
+++ b/powerpoints/Introduction.pptx
@@ -5655,19 +5655,19 @@
           <a:p>
             <a:r>
               <a:rPr lang="en-US" sz="2600" dirty="0"/>
-              <a:t>You can use it</a:t>
-            </a:r>
+              <a:t>You can </a:t>
+            </a:r>
+            <a:r>
+              <a:rPr lang="en-US" sz="2600"/>
+              <a:t>use it.</a:t>
+            </a:r>
+            <a:endParaRPr lang="en-US" sz="2600" dirty="0"/>
           </a:p>
           <a:p>
             <a:r>
               <a:rPr lang="en-US" sz="2600" dirty="0"/>
-              <a:t>Understanding how things work will enhance your ability to utilize </a:t>
-            </a:r>
-            <a:r>
-              <a:rPr lang="en-US" sz="2600"/>
-              <a:t>these tools</a:t>
-            </a:r>
-            <a:endParaRPr lang="en-US" sz="2600" dirty="0"/>
+              <a:t>Understanding how things work will enhance your ability to utilize these tools.</a:t>
+            </a:r>
           </a:p>
         </p:txBody>
       </p:sp>

</xml_diff>